<commit_message>
Imported .csv file in main.py and added powerpoint presentation.
</commit_message>
<xml_diff>
--- a/Data Exploration Presentation.pptx
+++ b/Data Exploration Presentation.pptx
@@ -3857,12 +3857,16 @@
           <a:p>
             <a:pPr algn="just"/>
             <a:r>
-              <a:rPr lang="en-US" sz="2800" dirty="0">
+              <a:rPr lang="en-US" sz="2800">
                 <a:latin typeface="Arial Rounded MT Bold" panose="020F0704030504030204" pitchFamily="34" charset="77"/>
                 <a:cs typeface="Chakra Petch" pitchFamily="2" charset="-34"/>
               </a:rPr>
               <a:t>Kyle Drewes</a:t>
             </a:r>
+            <a:endParaRPr lang="en-US" sz="2800" dirty="0">
+              <a:latin typeface="Arial Rounded MT Bold" panose="020F0704030504030204" pitchFamily="34" charset="77"/>
+              <a:cs typeface="Chakra Petch" pitchFamily="2" charset="-34"/>
+            </a:endParaRPr>
           </a:p>
           <a:p>
             <a:endParaRPr lang="en-US" sz="3200" dirty="0">

</xml_diff>